<commit_message>
M16: regenerate saltmarsh-environmental under the wave's knobs (baseline)
Wholesale regen through the live airlock (claude-opus-4-8[1m], xhigh).
Baseline realism: business_calendar (0 weekend meetings), book_is_sample,
style_specs (10 specs), voice_diversify. Scans + OCR layer + multi-affiliation
boundary person all retained. Validates clean (29 rules, 0 errors); 31
authored docs 0 off brief; self-scores 100%; byte-pin re-derives; org-tier
green.
</commit_message>
<xml_diff>
--- a/companies/saltmarsh-environmental/Engagements/Dyer and Sons/2015.07.10 - Briefing Deck - Dyer and Sons.pptx
+++ b/companies/saltmarsh-environmental/Engagements/Dyer and Sons/2015.07.10 - Briefing Deck - Dyer and Sons.pptx
@@ -3114,7 +3114,7 @@
                   <a:srgbClr val="3B3060"/>
                 </a:solidFill>
               </a:rPr>
-              <a:t>Wetland Delineation: Dyer and Sons</a:t>
+              <a:t>Wetland Delineation for Dyer and Sons</a:t>
             </a:r>
           </a:p>
         </p:txBody>
@@ -3141,25 +3141,25 @@
           <a:p>
             <a:pPr lvl="1"/>
             <a:r>
-              <a:t>Progress briefing prepared for Sandra Little, Director of Operations, Dyer and Sons</a:t>
+              <a:t>Prepared for Sandra Little, Dyer and Sons</a:t>
             </a:r>
           </a:p>
           <a:p>
             <a:pPr lvl="1"/>
             <a:r>
-              <a:t>Prepared by Saltmarsh Environmental Partners LLC</a:t>
+              <a:t>Purpose: establish the wetland boundary on the parcel before you build</a:t>
             </a:r>
           </a:p>
           <a:p>
             <a:pPr lvl="1"/>
             <a:r>
-              <a:t>Engagement commenced May 25, 2015</a:t>
+              <a:t>Client of record: Dyer and Sons</a:t>
             </a:r>
           </a:p>
           <a:p>
             <a:pPr lvl="1"/>
             <a:r>
-              <a:t>Delineation lead: John Sanchez, Senior Scientist</a:t>
+              <a:t>Fieldwork commenced May 25, 2015</a:t>
             </a:r>
           </a:p>
         </p:txBody>
@@ -3203,7 +3203,7 @@
                   <a:srgbClr val="3B3060"/>
                 </a:solidFill>
               </a:rPr>
-              <a:t>Scope and Method</a:t>
+              <a:t>What We Are Doing, and Why</a:t>
             </a:r>
           </a:p>
         </p:txBody>
@@ -3225,31 +3225,25 @@
           <a:p>
             <a:pPr lvl="1"/>
             <a:r>
-              <a:t>Wetland boundary delineated under the 1987 Corps manual and the applicable regional supplement</a:t>
+              <a:t>You need a wetland line drawn before the parcel can be developed.</a:t>
             </a:r>
           </a:p>
           <a:p>
             <a:pPr lvl="1"/>
             <a:r>
-              <a:t>Three parameters examined at paired sample points: hydrology, hydric soils, hydrophytic vegetation</a:t>
+              <a:t>We draw it to the 1987 Corps of Engineers Wetland Delineation Manual and the regional supplement.</a:t>
             </a:r>
           </a:p>
           <a:p>
             <a:pPr lvl="1"/>
             <a:r>
-              <a:t>Boundary flagged in the field and located by sub-meter GPS</a:t>
+              <a:t>The line rests on three things read on the ground: vegetation, soils, and hydrology.</a:t>
             </a:r>
           </a:p>
           <a:p>
             <a:pPr lvl="1"/>
             <a:r>
-              <a:t>Deliverable is a delineation report with figures, data forms, and a photograph log</a:t>
-            </a:r>
-          </a:p>
-          <a:p>
-            <a:pPr lvl="1"/>
-            <a:r>
-              <a:t>The report supports an agency determination; it is not itself a determination</a:t>
+              <a:t>Once it is walked and surveyed, it becomes the basis for a jurisdictional determination from the Corps.</a:t>
             </a:r>
           </a:p>
         </p:txBody>
@@ -3293,7 +3287,7 @@
                   <a:srgbClr val="3B3060"/>
                 </a:solidFill>
               </a:rPr>
-              <a:t>Work Completed to Date</a:t>
+              <a:t>How the Fieldwork Runs</a:t>
             </a:r>
           </a:p>
         </p:txBody>
@@ -3315,31 +3309,31 @@
           <a:p>
             <a:pPr lvl="1"/>
             <a:r>
-              <a:t>Background review complete: historical aerials, NWI mapping, county soil survey, prior permit record</a:t>
+              <a:t>Angela Williams and Mary Foster walk the parcel and flag the boundary in the field.</a:t>
             </a:r>
           </a:p>
           <a:p>
             <a:pPr lvl="1"/>
             <a:r>
-              <a:t>Reconnaissance walked by John Sanchez and Mary Foster; sample design fixed on the aerial</a:t>
+              <a:t>At each stretch we record paired sample points, one inside the line and one outside it.</a:t>
             </a:r>
           </a:p>
           <a:p>
             <a:pPr lvl="1"/>
             <a:r>
-              <a:t>Sample point pairs established across the upland transition; soil profiles described at each</a:t>
+              <a:t>Soils are described at the pit and sediment is logged as we go, not from memory afterward.</a:t>
             </a:r>
           </a:p>
           <a:p>
             <a:pPr lvl="1"/>
             <a:r>
-              <a:t>Boundary flagging underway on the western and southern margins</a:t>
+              <a:t>John Sanchez leads the technical work and writes the report the determination rests on.</a:t>
             </a:r>
           </a:p>
           <a:p>
             <a:pPr lvl="1"/>
             <a:r>
-              <a:t>Field conditions, tide stage, and antecedent precipitation logged for every field day</a:t>
+              <a:t>We work the visits around the tides, so the schedule follows the water rather than the calendar.</a:t>
             </a:r>
           </a:p>
         </p:txBody>
@@ -3383,7 +3377,7 @@
                   <a:srgbClr val="3B3060"/>
                 </a:solidFill>
               </a:rPr>
-              <a:t>Preliminary Observations</a:t>
+              <a:t>Where We Stand Today</a:t>
             </a:r>
           </a:p>
         </p:txBody>
@@ -3405,31 +3399,31 @@
           <a:p>
             <a:pPr lvl="1"/>
             <a:r>
-              <a:t>Wetland is present on the parcel; the question is where the line falls, not whether there is one</a:t>
+              <a:t>Flagging is underway across the accessible portions of the parcel.</a:t>
             </a:r>
           </a:p>
           <a:p>
             <a:pPr lvl="1"/>
             <a:r>
-              <a:t>Upland transition on the western margin is well expressed and was flagged without difficulty</a:t>
+              <a:t>Data forms are being completed at each paired point as we walk it.</a:t>
             </a:r>
           </a:p>
           <a:p>
             <a:pPr lvl="1"/>
             <a:r>
-              <a:t>The ditch corridor is unresolved: hydrology indicators are present, soil indicators are marginal</a:t>
+              <a:t>One reach along the channel is being resampled before we commit to a line there.</a:t>
             </a:r>
           </a:p>
           <a:p>
             <a:pPr lvl="1"/>
             <a:r>
-              <a:t>Fill of uncertain age near the access road may bear on the boundary and on the background record</a:t>
+              <a:t>Nothing is drawn as final until the whole boundary has been walked.</a:t>
             </a:r>
           </a:p>
           <a:p>
             <a:pPr lvl="1"/>
             <a:r>
-              <a:t>These are field observations, not findings; nothing here should be relied on until the report is issued</a:t>
+              <a:t>We report what we see at the flag line, not what the map suggests.</a:t>
             </a:r>
           </a:p>
         </p:txBody>
@@ -3473,7 +3467,7 @@
                   <a:srgbClr val="3B3060"/>
                 </a:solidFill>
               </a:rPr>
-              <a:t>Roles and Record</a:t>
+              <a:t>What You Get at the End</a:t>
             </a:r>
           </a:p>
         </p:txBody>
@@ -3495,31 +3489,25 @@
           <a:p>
             <a:pPr lvl="1"/>
             <a:r>
-              <a:t>John Sanchez establishes the sample points, describes the soil profiles, and owns the boundary</a:t>
+              <a:t>A delineation report that states what was found at each point and why the line sits where it does.</a:t>
             </a:r>
           </a:p>
           <a:p>
             <a:pPr lvl="1"/>
             <a:r>
-              <a:t>Mary Foster keeps the field record: personnel, weather, tide stage, antecedent precipitation, deviations</a:t>
+              <a:t>Figures showing the flagged boundary tied to a survey drawing.</a:t>
             </a:r>
           </a:p>
           <a:p>
             <a:pPr lvl="1"/>
             <a:r>
-              <a:t>Angela Williams surveys the flag positions and prepares the report and figures</a:t>
+              <a:t>A request for a jurisdictional determination, submitted to the Corps on your behalf.</a:t>
             </a:r>
           </a:p>
           <a:p>
             <a:pPr lvl="1"/>
             <a:r>
-              <a:t>Every deliverable is reviewed by the Managing Principal before it is issued</a:t>
-            </a:r>
-          </a:p>
-          <a:p>
-            <a:pPr lvl="1"/>
-            <a:r>
-              <a:t>The record is written for an agency reviewer opening the file years from now</a:t>
+              <a:t>A field record behind all of it that a reviewer can follow years from now.</a:t>
             </a:r>
           </a:p>
         </p:txBody>
@@ -3563,7 +3551,7 @@
                   <a:srgbClr val="3B3060"/>
                 </a:solidFill>
               </a:rPr>
-              <a:t>Next Steps</a:t>
+              <a:t>What Comes Next</a:t>
             </a:r>
           </a:p>
         </p:txBody>
@@ -3585,31 +3573,25 @@
           <a:p>
             <a:pPr lvl="1"/>
             <a:r>
-              <a:t>Complete flagging on the northern margin and re-walk the full line</a:t>
+              <a:t>Finish flagging the remaining boundary.</a:t>
             </a:r>
           </a:p>
           <a:p>
             <a:pPr lvl="1"/>
             <a:r>
-              <a:t>Additional sample point pairs in the ditch corridor to resolve the marginal soils</a:t>
+              <a:t>Bring in the survey crew to tie the flags to a drawing.</a:t>
             </a:r>
           </a:p>
           <a:p>
             <a:pPr lvl="1"/>
             <a:r>
-              <a:t>Angela Williams to survey the flag positions and begin the figure set</a:t>
+              <a:t>Draft the delineation report and the jurisdictional determination request.</a:t>
             </a:r>
           </a:p>
           <a:p>
             <a:pPr lvl="1"/>
             <a:r>
-              <a:t>Draft report to Managing Principal review before any copy is issued to Dyer and Sons</a:t>
-            </a:r>
-          </a:p>
-          <a:p>
-            <a:pPr lvl="1"/>
-            <a:r>
-              <a:t>Sandra Little to confirm continued site access for the remaining field days</a:t>
+              <a:t>Walk the flagged line with you before any of it goes to the agency.</a:t>
             </a:r>
           </a:p>
         </p:txBody>

</xml_diff>